<commit_message>
feat(authors): update author order with Barker first and Porterfield last across manuscript, site, and presentation
</commit_message>
<xml_diff>
--- a/Near_Null_Magnetic_Fields_Lunar_Plant_Biology_Presentation.pptx
+++ b/Near_Null_Magnetic_Fields_Lunar_Plant_Biology_Presentation.pptx
@@ -531,7 +531,7 @@
           </a:p>
           <a:p>
             <a:r>
-              <a:t>• Co-authored with Marshall Porterfield, Caue Borlina, Aubrey O'Rourke, Ray Wheeler and Gioia Massa at NASA KSC, Barbara Demmig-Adams at CU Boulder, and Christine Chamberlain at Space Lab Technologies.</a:t>
+              <a:t>• Co-authored with Marshall Porterfield, Caue Borlina, Aubrey O'Rourke, Adriana Sanchez, Manisha Dagar, Sofia Leiva Aldana, Ray Wheeler, Gioia Massa, Barbara Demmig-Adams, Marta Peirats-Llobet, Pamela Flores, Anirudha Dixit, and Christine Chamberlain.</a:t>
             </a:r>
           </a:p>
           <a:p>
@@ -5105,11 +5105,11 @@
               </a:defRPr>
             </a:pPr>
             <a:r>
-              <a:t>D. Marshall Porterfield*, Richard J. Barker*, Caue Borlina, Aubrey O’Rourke, Adriana Sanchez, Manisha Dagar,</a:t>
+              <a:t>Richard J. Barker*, Caue Borlina, Aubrey O’Rourke, Adriana Sanchez, Manisha Dagar, Sofia Leiva Aldana,</a:t>
             </a:r>
             <a:br/>
             <a:r>
-              <a:t>Sofia Leiva Aldana, Ray Wheeler, Gioia Massa, Barbara Demmig-Adams, Marta Peirats-Llobet, Pamela Flores, Anirudha Dixit, Christine Chamberlain</a:t>
+              <a:t>Ray Wheeler, Gioia Massa, Barbara Demmig-Adams, Marta Peirats-Llobet, Pamela Flores, Anirudha Dixit, Christine Chamberlain, D. Marshall Porterfield*</a:t>
             </a:r>
           </a:p>
           <a:p>
@@ -5121,11 +5121,11 @@
               </a:defRPr>
             </a:pPr>
             <a:r>
-              <a:t>Purdue University • NASA Kennedy Space Center • University of Colorado Boulder • Space Lab Technologies • La Trobe University</a:t>
+              <a:t>La Trobe University • Space Lab Technologies • NASA Kennedy Space Center • University of Colorado Boulder • Purdue University</a:t>
             </a:r>
             <a:br/>
             <a:r>
-              <a:t>*Corresponding Authors: porterf@purdue.edu, dr.richard.barker@gmail.com</a:t>
+              <a:t>*Corresponding Authors: dr.richard.barker@gmail.com, porterf@purdue.edu</a:t>
             </a:r>
           </a:p>
         </p:txBody>

</xml_diff>

<commit_message>
feat: align author ordering with Porterfield first, integrate AOR review feedback, redesign Figure 5 pipeline, and add supplemental corpus tables S1-S2
</commit_message>
<xml_diff>
--- a/Near_Null_Magnetic_Fields_Lunar_Plant_Biology_Presentation.pptx
+++ b/Near_Null_Magnetic_Fields_Lunar_Plant_Biology_Presentation.pptx
@@ -711,27 +711,27 @@
           </a:p>
           <a:p>
             <a:r>
-              <a:t>• Figure 5 is our operational blueprint for NASA and commercial spaceflight developers.</a:t>
-            </a:r>
-          </a:p>
-          <a:p>
-            <a:r>
-              <a:t>• Panel (a) lays out our 3-chamber ground simulation standard. Historically, studies compared an ambient room to a mu-metal box without controlling for ohmic heat or fan airflow. We mandate: Chamber 1 (GMF control), Chamber 2 (Shielded/Cancelled NNMF), and Chamber 3 (Bifilar sham control with current matched but net magnetic field zero).</a:t>
-            </a:r>
-          </a:p>
-          <a:p>
-            <a:r>
-              <a:t>• Panel (b) illustrates flight hardware integration. A miniature 3-axis fluxgate sensor (0.1 nT resolution) placed equidistant between seedling cassettes records real-time exposure.</a:t>
-            </a:r>
-          </a:p>
-          <a:p>
-            <a:r>
-              <a:t>• Panel (c) is the causal rescue protocol: Re-applying a 45 µT vector inside the chamber rescues germination speed and HY5 pigment accumulation, establishing definitive causal proof.</a:t>
-            </a:r>
-          </a:p>
-          <a:p>
-            <a:r>
-              <a:t>• Panel (d) defines predeclared operational flight decision gates: Green, Amber, and Red.</a:t>
+              <a:t>• Figure 5 establishes our translational roadmap, strictly separating laboratory ground standards from flight engineering trade spaces.</a:t>
+            </a:r>
+          </a:p>
+          <a:p>
+            <a:r>
+              <a:t>• Panel (a) sets the 3-chamber ground standard: Chamber 1 (GMF control), Chamber 2 (Shielded/Cancelled NNMF), and Chamber 3 (Bifilar sham control matching current, heat, and vibration without magnetic fields).</a:t>
+            </a:r>
+          </a:p>
+          <a:p>
+            <a:r>
+              <a:t>• Panel (b) addresses a critical question from flight engineers: What can realistically be accommodated? We recommend passive 3-axis magnetometry (&lt;1 W, grams of mass) at the plant canopy level, while leaving heavy active cancellation coils in ground facilities.</a:t>
+            </a:r>
+          </a:p>
+          <a:p>
+            <a:r>
+              <a:t>• Panel (c) demonstrates in situ causal rescue: Restoring 45 µT inside magnetic shielding rescues emergence speed and pigment accumulation, definitively ruling out microclimatic or enclosure artifacts.</a:t>
+            </a:r>
+          </a:p>
+          <a:p>
+            <a:r>
+              <a:t>• Panel (d) introduces our post-flight phenotypic disambiguation framework to distinguish hypomagnetic effects from microgravity and cosmic radiation.</a:t>
             </a:r>
           </a:p>
         </p:txBody>
@@ -801,37 +801,42 @@
           <a:lstStyle/>
           <a:p>
             <a:r>
-              <a:t>TALKING POINTS (SLIDE 12 - TABLE 3 DEEP DIVE):</a:t>
-            </a:r>
-          </a:p>
-          <a:p>
-            <a:r>
-              <a:t>• This is Table 3 from the paper, built as a native PowerPoint table so you can edit the numbers or thresholds directly for specific payload proposals.</a:t>
-            </a:r>
-          </a:p>
-          <a:p>
-            <a:r>
-              <a:t>• Spaceflight payload teams often struggle because decision criteria are not declared in advance. If seedlings don't emerge as planned on the Moon, payload operators are caught off guard.</a:t>
-            </a:r>
-          </a:p>
-          <a:p>
-            <a:r>
-              <a:t>• Green Gate represents nominal science: field is below 5 nT, germination is normal (≥85%), we proceed autonomously.</a:t>
-            </a:r>
-          </a:p>
-          <a:p>
-            <a:r>
-              <a:t>• Amber Gate is triggered if field ripples between 5 and 50 nT, or if emergence lags by 18 hours. We increase optical imaging frequency and correlate with lander bus power telemetry.</a:t>
-            </a:r>
-          </a:p>
-          <a:p>
-            <a:r>
-              <a:t>• Red Gate is our contingency countermeasure: If germination drops by more than 30%, or seedlings exhibit severe chlorosis, the ground team commands the activation of active 45 µT Helmholtz coils to re-apply Earth's geomagnetic field.</a:t>
-            </a:r>
-          </a:p>
-          <a:p>
-            <a:r>
-              <a:t>• This rescues crop viability and provides an ironclad causal demonstration.</a:t>
+              <a:t>TALKING POINTS (SLIDE 12 - PHENOTYPIC DISAMBIGUATION MATRIX):</a:t>
+            </a:r>
+          </a:p>
+          <a:p>
+            <a:r>
+              <a:t>• This table represents our key translational science recommendation for Artemis payloads and lunar greenhouses.</a:t>
+            </a:r>
+          </a:p>
+          <a:p>
+            <a:r>
+              <a:t>• When plants show stress on the lunar surface, how do we know if it was hypomagnetic stress, partial gravity (0.166 g), or radiation?</a:t>
+            </a:r>
+          </a:p>
+          <a:p>
+            <a:r>
+              <a:t>• This matrix provides unambiguous diagnostic markers:</a:t>
+            </a:r>
+          </a:p>
+          <a:p>
+            <a:r>
+              <a:t>  1. Hypomagnetic field delays emergence velocity (Δt50 = +12–36 h), represses chlorophyll/anthocyanin synthesis via cryptochromes, and triggers mitochondrial AOX1D without nuclear DNA damage. In ground controls, it is fully rescued by a 45 µT vector.</a:t>
+            </a:r>
+          </a:p>
+          <a:p>
+            <a:r>
+              <a:t>  2. Lunar partial gravity causes directional skewing and cell wall changes, but germination rate and greening are normal. It is rescued by a 1g centrifuge, but unaffected by magnetic fields.</a:t>
+            </a:r>
+          </a:p>
+          <a:p>
+            <a:r>
+              <a:t>  3. Radiation causes double-strand DNA breaks and γ-H2AX foci, which are independent of magnetic fields or gravity.</a:t>
+            </a:r>
+          </a:p>
+          <a:p>
+            <a:r>
+              <a:t>• This framework replaces arbitrary mission abort criteria with a rigorous post-flight diagnostic methodology.</a:t>
             </a:r>
           </a:p>
         </p:txBody>
@@ -5105,11 +5110,11 @@
               </a:defRPr>
             </a:pPr>
             <a:r>
-              <a:t>Richard J. Barker*, Caue Borlina, Aubrey O’Rourke, Adriana Sanchez, Manisha Dagar, Sofia Leiva Aldana,</a:t>
+              <a:t>D. Marshall Porterfield*, Richard J. Barker*, Caue Borlina, Aubrey O’Rourke, Adriana Sanchez, Manisha Dagar, Sofia Leiva Aldana,</a:t>
             </a:r>
             <a:br/>
             <a:r>
-              <a:t>Ray Wheeler, Gioia Massa, Barbara Demmig-Adams, Marta Peirats-Llobet, Pamela Flores, Anirudha Dixit, Christine Chamberlain, D. Marshall Porterfield*</a:t>
+              <a:t>Ray Wheeler, Gioia Massa, Barbara Demmig-Adams, Marta Peirats-Llobet, Pamela Flores, Anirudha Dixit, Christine Chamberlain</a:t>
             </a:r>
           </a:p>
           <a:p>
@@ -5729,7 +5734,7 @@
               </a:defRPr>
             </a:pPr>
             <a:r>
-              <a:t>Flight Validation, Causal Rescue &amp; Artemis Risk Pipeline</a:t>
+              <a:t>Scientific Knowledge Gap Retirement &amp; Flight Trade Space</a:t>
             </a:r>
           </a:p>
         </p:txBody>
@@ -5764,7 +5769,7 @@
               </a:defRPr>
             </a:pPr>
             <a:r>
-              <a:t>3-chamber ground controls, in-situ 3-axis fluxgate telemetry, active 45 µT rescue coils, and predeclared flight gates</a:t>
+              <a:t>3-chamber ground controls, in situ causal rescue, flight payload constraints, and phenotypic disambiguation</a:t>
             </a:r>
           </a:p>
         </p:txBody>
@@ -5972,7 +5977,7 @@
               </a:defRPr>
             </a:pPr>
             <a:r>
-              <a:t>(b) In-Chamber 3-Axis Fluxgate Magnetometer Telemetry</a:t>
+              <a:t>(b) Flight Payload Trade Space: Science Gaps vs. Engineering Limits</a:t>
             </a:r>
           </a:p>
         </p:txBody>
@@ -6076,7 +6081,7 @@
               </a:defRPr>
             </a:pPr>
             <a:r>
-              <a:t>(c) Active Causal Rescue: 40–50 µT Vector Re-Application</a:t>
+              <a:t>(c) In Situ Causal Rescue: 45 µT Vector Re-Application Proof</a:t>
             </a:r>
           </a:p>
         </p:txBody>
@@ -6180,7 +6185,7 @@
               </a:defRPr>
             </a:pPr>
             <a:r>
-              <a:t>(d) Predeclared Operational Flight Decision Gates</a:t>
+              <a:t>(d) Post-Flight Phenotypic Disambiguation Framework</a:t>
             </a:r>
           </a:p>
         </p:txBody>
@@ -6311,7 +6316,7 @@
               </a:defRPr>
             </a:pPr>
             <a:r>
-              <a:t>Artemis III LEAF Predeclared Operational Decision Gates</a:t>
+              <a:t>Phenotypic Risk Disambiguation Matrix for Lunar Plant Biology</a:t>
             </a:r>
           </a:p>
         </p:txBody>
@@ -6346,7 +6351,7 @@
               </a:defRPr>
             </a:pPr>
             <a:r>
-              <a:t>Pre-agreed quantitative decision thresholds to ensure rigorous science and safeguard lunar crop viability</a:t>
+              <a:t>Diagnostic criteria to decouple Near-Null Magnetic Fields from Lunar Partial Gravity and Deep-Space Radiation</a:t>
             </a:r>
           </a:p>
         </p:txBody>
@@ -6370,10 +6375,10 @@
                 <a:tableStyleId>{5C22544A-7EE6-4342-B048-85BDC9FD1C3A}</a:tableStyleId>
               </a:tblPr>
               <a:tblGrid>
-                <a:gridCol w="1645920"/>
-                <a:gridCol w="2377440"/>
-                <a:gridCol w="2926080"/>
-                <a:gridCol w="3779215"/>
+                <a:gridCol w="2011680"/>
+                <a:gridCol w="2560320"/>
+                <a:gridCol w="3291840"/>
+                <a:gridCol w="2864815"/>
               </a:tblGrid>
               <a:tr h="1120140">
                 <a:tc>
@@ -6382,14 +6387,14 @@
                     <a:lstStyle/>
                     <a:p>
                       <a:pPr>
-                        <a:defRPr sz="1000" b="1">
+                        <a:defRPr sz="950" b="1">
                           <a:solidFill>
                             <a:srgbClr val="F8FAFC"/>
                           </a:solidFill>
                         </a:defRPr>
                       </a:pPr>
                       <a:r>
-                        <a:t>Flight Decision Gate</a:t>
+                        <a:t>Environmental Stressor</a:t>
                       </a:r>
                     </a:p>
                   </a:txBody>
@@ -6405,14 +6410,14 @@
                     <a:lstStyle/>
                     <a:p>
                       <a:pPr>
-                        <a:defRPr sz="1000" b="1">
+                        <a:defRPr sz="950" b="1">
                           <a:solidFill>
                             <a:srgbClr val="F8FAFC"/>
                           </a:solidFill>
                         </a:defRPr>
                       </a:pPr>
                       <a:r>
-                        <a:t>Magnetic Field Telemetry</a:t>
+                        <a:t>Primary Cellular Target</a:t>
                       </a:r>
                     </a:p>
                   </a:txBody>
@@ -6428,14 +6433,14 @@
                     <a:lstStyle/>
                     <a:p>
                       <a:pPr>
-                        <a:defRPr sz="1000" b="1">
+                        <a:defRPr sz="950" b="1">
                           <a:solidFill>
                             <a:srgbClr val="F8FAFC"/>
                           </a:solidFill>
                         </a:defRPr>
                       </a:pPr>
                       <a:r>
-                        <a:t>Biological Metric Threshold</a:t>
+                        <a:t>Phenotypic Diagnostic Signature (Days 0–5)</a:t>
                       </a:r>
                     </a:p>
                   </a:txBody>
@@ -6451,14 +6456,14 @@
                     <a:lstStyle/>
                     <a:p>
                       <a:pPr>
-                        <a:defRPr sz="1000" b="1">
+                        <a:defRPr sz="950" b="1">
                           <a:solidFill>
                             <a:srgbClr val="F8FAFC"/>
                           </a:solidFill>
                         </a:defRPr>
                       </a:pPr>
                       <a:r>
-                        <a:t>Predeclared Operational Action</a:t>
+                        <a:t>Disambiguation Strategy</a:t>
                       </a:r>
                     </a:p>
                   </a:txBody>
@@ -6478,17 +6483,156 @@
                       <a:pPr>
                         <a:defRPr sz="900" b="1">
                           <a:solidFill>
+                            <a:srgbClr val="DC2626"/>
+                          </a:solidFill>
+                        </a:defRPr>
+                      </a:pPr>
+                      <a:r>
+                        <a:t>Near-Null Magnetic Field</a:t>
+                      </a:r>
+                    </a:p>
+                    <a:p>
+                      <a:r>
+                        <a:t>(NNMF, &lt; 10 nT)</a:t>
+                      </a:r>
+                    </a:p>
+                  </a:txBody>
+                  <a:tcPr anchor="ctr">
+                    <a:solidFill>
+                      <a:srgbClr val="FEF2F2"/>
+                    </a:solidFill>
+                  </a:tcPr>
+                </a:tc>
+                <a:tc>
+                  <a:txBody>
+                    <a:bodyPr/>
+                    <a:lstStyle/>
+                    <a:p>
+                      <a:pPr>
+                        <a:defRPr sz="850">
+                          <a:solidFill>
+                            <a:srgbClr val="0F172A"/>
+                          </a:solidFill>
+                        </a:defRPr>
+                      </a:pPr>
+                      <a:r>
+                        <a:t>Cryptochrome radical pairs</a:t>
+                      </a:r>
+                    </a:p>
+                    <a:p>
+                      <a:r>
+                        <a:t>[FAD•- ... TrpH•+];</a:t>
+                      </a:r>
+                    </a:p>
+                    <a:p>
+                      <a:r>
+                        <a:t>SDP1 triacylglycerol lipase.</a:t>
+                      </a:r>
+                    </a:p>
+                  </a:txBody>
+                  <a:tcPr anchor="ctr">
+                    <a:solidFill>
+                      <a:srgbClr val="F8FAFC"/>
+                    </a:solidFill>
+                  </a:tcPr>
+                </a:tc>
+                <a:tc>
+                  <a:txBody>
+                    <a:bodyPr/>
+                    <a:lstStyle/>
+                    <a:p>
+                      <a:pPr>
+                        <a:defRPr sz="800">
+                          <a:solidFill>
+                            <a:srgbClr val="0F172A"/>
+                          </a:solidFill>
+                        </a:defRPr>
+                      </a:pPr>
+                      <a:r>
+                        <a:t>• Emergence lag (Δt50 = +12–36 h)</a:t>
+                      </a:r>
+                    </a:p>
+                    <a:p>
+                      <a:r>
+                        <a:t>• 10%–30% capacity drop; chlorosis</a:t>
+                      </a:r>
+                    </a:p>
+                    <a:p>
+                      <a:r>
+                        <a:t>• Downregulated HEMA1/CHLH/POR</a:t>
+                      </a:r>
+                    </a:p>
+                    <a:p>
+                      <a:r>
+                        <a:t>• Mitochondrial AOX1D &amp; CAT3 leak</a:t>
+                      </a:r>
+                    </a:p>
+                    <a:p>
+                      <a:r>
+                        <a:t>• Minimal nuclear DNA breaks</a:t>
+                      </a:r>
+                    </a:p>
+                  </a:txBody>
+                  <a:tcPr anchor="ctr">
+                    <a:solidFill>
+                      <a:srgbClr val="F8FAFC"/>
+                    </a:solidFill>
+                  </a:tcPr>
+                </a:tc>
+                <a:tc>
+                  <a:txBody>
+                    <a:bodyPr/>
+                    <a:lstStyle/>
+                    <a:p>
+                      <a:pPr>
+                        <a:defRPr sz="819">
+                          <a:solidFill>
+                            <a:srgbClr val="0F172A"/>
+                          </a:solidFill>
+                        </a:defRPr>
+                      </a:pPr>
+                      <a:r>
+                        <a:t>• Reversible by in situ 45 µT vector re-application (causal rescue).</a:t>
+                      </a:r>
+                    </a:p>
+                    <a:p>
+                      <a:r>
+                        <a:t>• Insensitive to 1g spin centrifugation.</a:t>
+                      </a:r>
+                    </a:p>
+                    <a:p>
+                      <a:r>
+                        <a:t>• Correlates with 3-axis magnetometer canopy telemetry.</a:t>
+                      </a:r>
+                    </a:p>
+                  </a:txBody>
+                  <a:tcPr anchor="ctr">
+                    <a:solidFill>
+                      <a:srgbClr val="F8FAFC"/>
+                    </a:solidFill>
+                  </a:tcPr>
+                </a:tc>
+              </a:tr>
+              <a:tr h="1120140">
+                <a:tc>
+                  <a:txBody>
+                    <a:bodyPr/>
+                    <a:lstStyle/>
+                    <a:p>
+                      <a:pPr>
+                        <a:defRPr sz="900" b="1">
+                          <a:solidFill>
                             <a:srgbClr val="16A34A"/>
                           </a:solidFill>
                         </a:defRPr>
                       </a:pPr>
                       <a:r>
-                        <a:t>GREEN GATE</a:t>
+                        <a:t>Lunar Partial Gravity</a:t>
                       </a:r>
                     </a:p>
                     <a:p>
                       <a:r>
-                        <a:t>(Nominal Flight)</a:t>
+                        <a:t>(0.166 g) / Microgravity</a:t>
                       </a:r>
                     </a:p>
                   </a:txBody>
@@ -6504,30 +6648,30 @@
                     <a:lstStyle/>
                     <a:p>
                       <a:pPr>
-                        <a:defRPr sz="900">
+                        <a:defRPr sz="850">
                           <a:solidFill>
                             <a:srgbClr val="0F172A"/>
                           </a:solidFill>
                         </a:defRPr>
                       </a:pPr>
                       <a:r>
-                        <a:t>|B_total| &lt; 5.0 nT</a:t>
+                        <a:t>Amyloplast statolith sedimentation;</a:t>
                       </a:r>
                     </a:p>
                     <a:p>
                       <a:r>
-                        <a:t>Steady-state near-null field;</a:t>
+                        <a:t>Mechanosensitive ion channels (MSL/MCA);</a:t>
                       </a:r>
                     </a:p>
                     <a:p>
                       <a:r>
-                        <a:t>No lander EMI spikes (&gt;10 nT).</a:t>
+                        <a:t>PIN auxin carrier polarity.</a:t>
                       </a:r>
                     </a:p>
                   </a:txBody>
                   <a:tcPr anchor="ctr">
                     <a:solidFill>
-                      <a:srgbClr val="FFFFFF"/>
+                      <a:srgbClr val="F8FAFC"/>
                     </a:solidFill>
                   </a:tcPr>
                 </a:tc>
@@ -6537,30 +6681,40 @@
                     <a:lstStyle/>
                     <a:p>
                       <a:pPr>
-                        <a:defRPr sz="900">
+                        <a:defRPr sz="800">
                           <a:solidFill>
                             <a:srgbClr val="0F172A"/>
                           </a:solidFill>
                         </a:defRPr>
                       </a:pPr>
                       <a:r>
-                        <a:t>Germination Capacity ≥ 85%</a:t>
+                        <a:t>• Normal germination capacity</a:t>
                       </a:r>
                     </a:p>
                     <a:p>
                       <a:r>
-                        <a:t>Normal t50 emergence velocity;</a:t>
+                        <a:t>• Negligible emergence lag (Δt50 &lt; 4 h)</a:t>
                       </a:r>
                     </a:p>
                     <a:p>
                       <a:r>
-                        <a:t>Active hypocotyl greening.</a:t>
+                        <a:t>• Random root waving &amp; directional skewing</a:t>
+                      </a:r>
+                    </a:p>
+                    <a:p>
+                      <a:r>
+                        <a:t>• Normal plastid greening under PAR</a:t>
+                      </a:r>
+                    </a:p>
+                    <a:p>
+                      <a:r>
+                        <a:t>• Localized apoplastic ROS (RBOHD/F)</a:t>
                       </a:r>
                     </a:p>
                   </a:txBody>
                   <a:tcPr anchor="ctr">
                     <a:solidFill>
-                      <a:srgbClr val="FFFFFF"/>
+                      <a:srgbClr val="F8FAFC"/>
                     </a:solidFill>
                   </a:tcPr>
                 </a:tc>
@@ -6570,35 +6724,30 @@
                     <a:lstStyle/>
                     <a:p>
                       <a:pPr>
-                        <a:defRPr sz="900">
+                        <a:defRPr sz="819">
                           <a:solidFill>
                             <a:srgbClr val="0F172A"/>
                           </a:solidFill>
                         </a:defRPr>
                       </a:pPr>
                       <a:r>
-                        <a:t>Continue nominal autonomous flight timeline.</a:t>
+                        <a:t>• Fully rescued by onboard 1g centrifuge controls.</a:t>
                       </a:r>
                     </a:p>
                     <a:p>
                       <a:r>
-                        <a:t>• 10 Hz magnetometer logging.</a:t>
+                        <a:t>• Completely insensitive to static magnetic field manipulation.</a:t>
                       </a:r>
                     </a:p>
                     <a:p>
                       <a:r>
-                        <a:t>• 30-minute multispectral camera imaging.</a:t>
-                      </a:r>
-                    </a:p>
-                    <a:p>
-                      <a:r>
-                        <a:t>• Standard environmental controls.</a:t>
+                        <a:t>• Quantified via camera morphometry.</a:t>
                       </a:r>
                     </a:p>
                   </a:txBody>
                   <a:tcPr anchor="ctr">
                     <a:solidFill>
-                      <a:srgbClr val="FFFFFF"/>
+                      <a:srgbClr val="F8FAFC"/>
                     </a:solidFill>
                   </a:tcPr>
                 </a:tc>
@@ -6617,12 +6766,12 @@
                         </a:defRPr>
                       </a:pPr>
                       <a:r>
-                        <a:t>AMBER GATE</a:t>
+                        <a:t>Deep-Space Radiation</a:t>
                       </a:r>
                     </a:p>
                     <a:p>
                       <a:r>
-                        <a:t>(Investigation / Caution)</a:t>
+                        <a:t>(GCR / SPE)</a:t>
                       </a:r>
                     </a:p>
                   </a:txBody>
@@ -6638,30 +6787,30 @@
                     <a:lstStyle/>
                     <a:p>
                       <a:pPr>
-                        <a:defRPr sz="900">
+                        <a:defRPr sz="850">
                           <a:solidFill>
                             <a:srgbClr val="0F172A"/>
                           </a:solidFill>
                         </a:defRPr>
                       </a:pPr>
                       <a:r>
-                        <a:t>5.0 nT ≤ |B_total| ≤ 50 nT</a:t>
+                        <a:t>Direct nuclear DNA ionization;</a:t>
                       </a:r>
                     </a:p>
                     <a:p>
                       <a:r>
-                        <a:t>Intermittent lander DC ripple</a:t>
+                        <a:t>Radiolysis of H2O producing •OH;</a:t>
                       </a:r>
                     </a:p>
                     <a:p>
                       <a:r>
-                        <a:t>or unexpected local anomaly.</a:t>
+                        <a:t>Oxidation of Fe-S clusters.</a:t>
                       </a:r>
                     </a:p>
                   </a:txBody>
                   <a:tcPr anchor="ctr">
                     <a:solidFill>
-                      <a:srgbClr val="FFFFFF"/>
+                      <a:srgbClr val="F8FAFC"/>
                     </a:solidFill>
                   </a:tcPr>
                 </a:tc>
@@ -6671,30 +6820,40 @@
                     <a:lstStyle/>
                     <a:p>
                       <a:pPr>
-                        <a:defRPr sz="900">
+                        <a:defRPr sz="800">
                           <a:solidFill>
                             <a:srgbClr val="0F172A"/>
                           </a:solidFill>
                         </a:defRPr>
                       </a:pPr>
                       <a:r>
-                        <a:t>15% to 30% Emergence Delay</a:t>
+                        <a:t>• Emergence failure only at lethal doses</a:t>
                       </a:r>
                     </a:p>
                     <a:p>
                       <a:r>
-                        <a:t>(t50 lag &gt; 18 h) or mild seedling</a:t>
+                        <a:t>• Mitotic apical cell cycle arrest</a:t>
                       </a:r>
                     </a:p>
                     <a:p>
                       <a:r>
-                        <a:t>chlorosis detected.</a:t>
+                        <a:t>• Severe chromosomal aberrations</a:t>
+                      </a:r>
+                    </a:p>
+                    <a:p>
+                      <a:r>
+                        <a:t>• High γ-H2AX phosphorylated foci</a:t>
+                      </a:r>
+                    </a:p>
+                    <a:p>
+                      <a:r>
+                        <a:t>• Marked lipid peroxidation (MDA)</a:t>
                       </a:r>
                     </a:p>
                   </a:txBody>
                   <a:tcPr anchor="ctr">
                     <a:solidFill>
-                      <a:srgbClr val="FFFFFF"/>
+                      <a:srgbClr val="F8FAFC"/>
                     </a:solidFill>
                   </a:tcPr>
                 </a:tc>
@@ -6704,169 +6863,30 @@
                     <a:lstStyle/>
                     <a:p>
                       <a:pPr>
-                        <a:defRPr sz="900">
+                        <a:defRPr sz="819">
                           <a:solidFill>
                             <a:srgbClr val="0F172A"/>
                           </a:solidFill>
                         </a:defRPr>
                       </a:pPr>
                       <a:r>
-                        <a:t>Initiate secondary optical diagnostics.</a:t>
+                        <a:t>• Mitigated by passive polyethylene or water-wall shielding.</a:t>
                       </a:r>
                     </a:p>
                     <a:p>
                       <a:r>
-                        <a:t>• Command high-frequency imaging.</a:t>
+                        <a:t>• Independent of magnetic coils or centrifuges.</a:t>
                       </a:r>
                     </a:p>
                     <a:p>
                       <a:r>
-                        <a:t>• Cross-reference lander power bus telemetry.</a:t>
-                      </a:r>
-                    </a:p>
-                    <a:p>
-                      <a:r>
-                        <a:t>• Log potential electromagnetic interference.</a:t>
+                        <a:t>• Directly calibrated against active dosimeter telemetry (Gy).</a:t>
                       </a:r>
                     </a:p>
                   </a:txBody>
                   <a:tcPr anchor="ctr">
                     <a:solidFill>
-                      <a:srgbClr val="FFFFFF"/>
-                    </a:solidFill>
-                  </a:tcPr>
-                </a:tc>
-              </a:tr>
-              <a:tr h="1120140">
-                <a:tc>
-                  <a:txBody>
-                    <a:bodyPr/>
-                    <a:lstStyle/>
-                    <a:p>
-                      <a:pPr>
-                        <a:defRPr sz="900" b="1">
-                          <a:solidFill>
-                            <a:srgbClr val="DC2626"/>
-                          </a:solidFill>
-                        </a:defRPr>
-                      </a:pPr>
-                      <a:r>
-                        <a:t>RED GATE</a:t>
-                      </a:r>
-                    </a:p>
-                    <a:p>
-                      <a:r>
-                        <a:t>(Causal Intervention)</a:t>
-                      </a:r>
-                    </a:p>
-                  </a:txBody>
-                  <a:tcPr anchor="ctr">
-                    <a:solidFill>
-                      <a:srgbClr val="FEF2F2"/>
-                    </a:solidFill>
-                  </a:tcPr>
-                </a:tc>
-                <a:tc>
-                  <a:txBody>
-                    <a:bodyPr/>
-                    <a:lstStyle/>
-                    <a:p>
-                      <a:pPr>
-                        <a:defRPr sz="900">
-                          <a:solidFill>
-                            <a:srgbClr val="0F172A"/>
-                          </a:solidFill>
-                        </a:defRPr>
-                      </a:pPr>
-                      <a:r>
-                        <a:t>|B_total| &lt; 1.0 nT (Deep void)</a:t>
-                      </a:r>
-                    </a:p>
-                    <a:p>
-                      <a:r>
-                        <a:t>OR extreme uncontrolled</a:t>
-                      </a:r>
-                    </a:p>
-                    <a:p>
-                      <a:r>
-                        <a:t>EMI excursion (&gt;100 µT).</a:t>
-                      </a:r>
-                    </a:p>
-                  </a:txBody>
-                  <a:tcPr anchor="ctr">
-                    <a:solidFill>
-                      <a:srgbClr val="FFFFFF"/>
-                    </a:solidFill>
-                  </a:tcPr>
-                </a:tc>
-                <a:tc>
-                  <a:txBody>
-                    <a:bodyPr/>
-                    <a:lstStyle/>
-                    <a:p>
-                      <a:pPr>
-                        <a:defRPr sz="900">
-                          <a:solidFill>
-                            <a:srgbClr val="0F172A"/>
-                          </a:solidFill>
-                        </a:defRPr>
-                      </a:pPr>
-                      <a:r>
-                        <a:t>Germination Capacity Drop &gt; 30%</a:t>
-                      </a:r>
-                    </a:p>
-                    <a:p>
-                      <a:r>
-                        <a:t>or severe arrest of de-etiolation</a:t>
-                      </a:r>
-                    </a:p>
-                    <a:p>
-                      <a:r>
-                        <a:t>and visible chlorosis by Day 5.</a:t>
-                      </a:r>
-                    </a:p>
-                  </a:txBody>
-                  <a:tcPr anchor="ctr">
-                    <a:solidFill>
-                      <a:srgbClr val="FFFFFF"/>
-                    </a:solidFill>
-                  </a:tcPr>
-                </a:tc>
-                <a:tc>
-                  <a:txBody>
-                    <a:bodyPr/>
-                    <a:lstStyle/>
-                    <a:p>
-                      <a:pPr>
-                        <a:defRPr sz="900">
-                          <a:solidFill>
-                            <a:srgbClr val="0F172A"/>
-                          </a:solidFill>
-                        </a:defRPr>
-                      </a:pPr>
-                      <a:r>
-                        <a:t>EXECUTE ACTIVE CAUSAL RESCUE:</a:t>
-                      </a:r>
-                    </a:p>
-                    <a:p>
-                      <a:r>
-                        <a:t>• Energize 3-axis compensation coils to re-apply 45 µT vector.</a:t>
-                      </a:r>
-                    </a:p>
-                    <a:p>
-                      <a:r>
-                        <a:t>• Restore terrestrial geomagnetic conditions.</a:t>
-                      </a:r>
-                    </a:p>
-                    <a:p>
-                      <a:r>
-                        <a:t>• Evaluate rescue of post-emergence seedling vigor.</a:t>
-                      </a:r>
-                    </a:p>
-                  </a:txBody>
-                  <a:tcPr anchor="ctr">
-                    <a:solidFill>
-                      <a:srgbClr val="FFFFFF"/>
+                      <a:srgbClr val="F8FAFC"/>
                     </a:solidFill>
                   </a:tcPr>
                 </a:tc>

</xml_diff>

<commit_message>
Polish Figure 1 B/D offsets and reframe Figure 5 into 3-panel ground standards & disambiguation layout
</commit_message>
<xml_diff>
--- a/Near_Null_Magnetic_Fields_Lunar_Plant_Biology_Presentation.pptx
+++ b/Near_Null_Magnetic_Fields_Lunar_Plant_Biology_Presentation.pptx
@@ -711,27 +711,22 @@
           </a:p>
           <a:p>
             <a:r>
-              <a:t>• Figure 5 establishes our translational roadmap, strictly separating laboratory ground standards from flight engineering trade spaces.</a:t>
-            </a:r>
-          </a:p>
-          <a:p>
-            <a:r>
-              <a:t>• Panel (a) sets the 3-chamber ground standard: Chamber 1 (GMF control), Chamber 2 (Shielded/Cancelled NNMF), and Chamber 3 (Bifilar sham control matching current, heat, and vibration without magnetic fields).</a:t>
-            </a:r>
-          </a:p>
-          <a:p>
-            <a:r>
-              <a:t>• Panel (b) addresses a critical question from flight engineers: What can realistically be accommodated? We recommend passive 3-axis magnetometry (&lt;1 W, grams of mass) at the plant canopy level, while leaving heavy active cancellation coils in ground facilities.</a:t>
-            </a:r>
-          </a:p>
-          <a:p>
-            <a:r>
-              <a:t>• Panel (c) demonstrates in situ causal rescue: Restoring 45 µT inside magnetic shielding rescues emergence speed and pigment accumulation, definitively ruling out microclimatic or enclosure artifacts.</a:t>
-            </a:r>
-          </a:p>
-          <a:p>
-            <a:r>
-              <a:t>• Panel (d) introduces our post-flight phenotypic disambiguation framework to distinguish hypomagnetic effects from microgravity and cosmic radiation.</a:t>
+              <a:t>• Figure 5 establishes our translational roadmap, focusing on rigorous ground simulation methods and post-flight disambiguation.</a:t>
+            </a:r>
+          </a:p>
+          <a:p>
+            <a:r>
+              <a:t>• Panel (a) sets the 3-chamber ground standard: Chamber 1 (GMF terrestrial control), Chamber 2 (Shielded/Cancelled NNMF lunar simulation), and Chamber 3 (Bifilar sham control matching current, heat, and vibration without magnetic fields).</a:t>
+            </a:r>
+          </a:p>
+          <a:p>
+            <a:r>
+              <a:t>• Panel (b) demonstrates the gold-standard in situ causal reversal protocol: Restoring a calibrated 45 µT vector inside magnetic shielding rescues emergence speed and pigment accumulation, definitively ruling out microclimatic, ethylene, or enclosure artifacts.</a:t>
+            </a:r>
+          </a:p>
+          <a:p>
+            <a:r>
+              <a:t>• Panel (c) provides our post-flight phenotypic disambiguation framework: A full comparative matrix distinguishing hypomagnetic lesions from lunar partial gravity (0.166 g) and deep-space cosmic radiation (GCR) using specific cellular targets and diagnostic rescue strategies.</a:t>
             </a:r>
           </a:p>
         </p:txBody>
@@ -5734,7 +5729,7 @@
               </a:defRPr>
             </a:pPr>
             <a:r>
-              <a:t>Scientific Knowledge Gap Retirement &amp; Flight Trade Space</a:t>
+              <a:t>Ground Simulation Standards &amp; Post-Flight Disambiguation</a:t>
             </a:r>
           </a:p>
         </p:txBody>
@@ -5769,7 +5764,7 @@
               </a:defRPr>
             </a:pPr>
             <a:r>
-              <a:t>3-chamber ground controls, in situ causal rescue, flight payload constraints, and phenotypic disambiguation</a:t>
+              <a:t>3-chamber ground controls, in situ causal rescue proof-of-concept, and post-flight phenotypic disambiguation framework</a:t>
             </a:r>
           </a:p>
         </p:txBody>
@@ -5783,7 +5778,7 @@
         <p:spPr>
           <a:xfrm>
             <a:off x="731520" y="1600200"/>
-            <a:ext cx="5212080" cy="2240280"/>
+            <a:ext cx="5212080" cy="2194560"/>
           </a:xfrm>
           <a:prstGeom prst="roundRect">
             <a:avLst/>
@@ -5836,7 +5831,7 @@
         <p:spPr>
           <a:xfrm>
             <a:off x="822960" y="1920240"/>
-            <a:ext cx="5029200" cy="1856232"/>
+            <a:ext cx="5029200" cy="1810512"/>
           </a:xfrm>
           <a:prstGeom prst="rect">
             <a:avLst/>
@@ -5873,7 +5868,7 @@
               </a:defRPr>
             </a:pPr>
             <a:r>
-              <a:t>(a) Methodological Ground Simulation &amp; 3-Chamber Parity</a:t>
+              <a:t>(a) Methodological Ground Simulation Standards (3-Chamber Parity)</a:t>
             </a:r>
           </a:p>
         </p:txBody>
@@ -5887,7 +5882,7 @@
         <p:spPr>
           <a:xfrm>
             <a:off x="6248095" y="1600200"/>
-            <a:ext cx="5212080" cy="2240280"/>
+            <a:ext cx="5212080" cy="2194560"/>
           </a:xfrm>
           <a:prstGeom prst="roundRect">
             <a:avLst/>
@@ -5925,7 +5920,7 @@
       </p:sp>
       <p:pic>
         <p:nvPicPr>
-          <p:cNvPr id="9" name="Picture 8" descr="Fig5b_flight_telemetry.png"/>
+          <p:cNvPr id="9" name="Picture 8" descr="Fig5b_causal_rescue.png"/>
           <p:cNvPicPr>
             <a:picLocks noChangeAspect="1"/>
           </p:cNvPicPr>
@@ -5940,7 +5935,7 @@
         <p:spPr>
           <a:xfrm>
             <a:off x="6339535" y="1920240"/>
-            <a:ext cx="5029200" cy="1856232"/>
+            <a:ext cx="5029200" cy="1810512"/>
           </a:xfrm>
           <a:prstGeom prst="rect">
             <a:avLst/>
@@ -5977,7 +5972,7 @@
               </a:defRPr>
             </a:pPr>
             <a:r>
-              <a:t>(b) Flight Payload Trade Space: Science Gaps vs. Engineering Limits</a:t>
+              <a:t>(b) In Situ Causal Reversal Protocol (Proof of Concept)</a:t>
             </a:r>
           </a:p>
         </p:txBody>
@@ -5990,8 +5985,8 @@
         </p:nvSpPr>
         <p:spPr>
           <a:xfrm>
-            <a:off x="731520" y="4069080"/>
-            <a:ext cx="5212080" cy="2240280"/>
+            <a:off x="731520" y="3977639"/>
+            <a:ext cx="10728655" cy="2331720"/>
           </a:xfrm>
           <a:prstGeom prst="roundRect">
             <a:avLst/>
@@ -6029,7 +6024,7 @@
       </p:sp>
       <p:pic>
         <p:nvPicPr>
-          <p:cNvPr id="12" name="Picture 11" descr="Fig5c_causal_rescue.png"/>
+          <p:cNvPr id="12" name="Picture 11" descr="Fig5c_decision_matrix.png"/>
           <p:cNvPicPr>
             <a:picLocks noChangeAspect="1"/>
           </p:cNvPicPr>
@@ -6043,8 +6038,8 @@
         </p:blipFill>
         <p:spPr>
           <a:xfrm>
-            <a:off x="822960" y="4389120"/>
-            <a:ext cx="5029200" cy="1856232"/>
+            <a:off x="822960" y="4297679"/>
+            <a:ext cx="10545775" cy="1947672"/>
           </a:xfrm>
           <a:prstGeom prst="rect">
             <a:avLst/>
@@ -6059,8 +6054,8 @@
         </p:nvSpPr>
         <p:spPr>
           <a:xfrm>
-            <a:off x="868680" y="4114800"/>
-            <a:ext cx="5212080" cy="274320"/>
+            <a:off x="868680" y="4023359"/>
+            <a:ext cx="10728655" cy="274320"/>
           </a:xfrm>
           <a:prstGeom prst="rect">
             <a:avLst/>
@@ -6081,118 +6076,14 @@
               </a:defRPr>
             </a:pPr>
             <a:r>
-              <a:t>(c) In Situ Causal Rescue: 45 µT Vector Re-Application Proof</a:t>
-            </a:r>
-          </a:p>
-        </p:txBody>
-      </p:sp>
-      <p:sp>
-        <p:nvSpPr>
-          <p:cNvPr id="14" name="Rounded Rectangle 13"/>
-          <p:cNvSpPr/>
-          <p:nvPr/>
-        </p:nvSpPr>
-        <p:spPr>
-          <a:xfrm>
-            <a:off x="6248095" y="4069080"/>
-            <a:ext cx="5212080" cy="2240280"/>
-          </a:xfrm>
-          <a:prstGeom prst="roundRect">
-            <a:avLst/>
-          </a:prstGeom>
-          <a:solidFill>
-            <a:srgbClr val="FFFFFF"/>
-          </a:solidFill>
-          <a:ln w="12700">
-            <a:solidFill>
-              <a:srgbClr val="E2E8F0"/>
-            </a:solidFill>
-          </a:ln>
-        </p:spPr>
-        <p:style>
-          <a:lnRef idx="1">
-            <a:schemeClr val="accent1"/>
-          </a:lnRef>
-          <a:fillRef idx="3">
-            <a:schemeClr val="accent1"/>
-          </a:fillRef>
-          <a:effectRef idx="2">
-            <a:schemeClr val="accent1"/>
-          </a:effectRef>
-          <a:fontRef idx="minor">
-            <a:schemeClr val="lt1"/>
-          </a:fontRef>
-        </p:style>
-        <p:txBody>
-          <a:bodyPr rtlCol="0" anchor="ctr"/>
-          <a:lstStyle/>
-          <a:p>
-            <a:pPr algn="ctr"/>
-          </a:p>
-        </p:txBody>
-      </p:sp>
-      <p:pic>
-        <p:nvPicPr>
-          <p:cNvPr id="15" name="Picture 14" descr="Fig5d_decision_matrix.png"/>
-          <p:cNvPicPr>
-            <a:picLocks noChangeAspect="1"/>
-          </p:cNvPicPr>
-          <p:nvPr/>
-        </p:nvPicPr>
-        <p:blipFill>
-          <a:blip r:embed="rId5"/>
-          <a:stretch>
-            <a:fillRect/>
-          </a:stretch>
-        </p:blipFill>
-        <p:spPr>
-          <a:xfrm>
-            <a:off x="6339535" y="4389120"/>
-            <a:ext cx="5029200" cy="1856232"/>
-          </a:xfrm>
-          <a:prstGeom prst="rect">
-            <a:avLst/>
-          </a:prstGeom>
-        </p:spPr>
-      </p:pic>
-      <p:sp>
-        <p:nvSpPr>
-          <p:cNvPr id="16" name="TextBox 15"/>
-          <p:cNvSpPr txBox="1"/>
-          <p:nvPr/>
-        </p:nvSpPr>
-        <p:spPr>
-          <a:xfrm>
-            <a:off x="6385255" y="4114800"/>
-            <a:ext cx="5212080" cy="274320"/>
-          </a:xfrm>
-          <a:prstGeom prst="rect">
-            <a:avLst/>
-          </a:prstGeom>
-          <a:noFill/>
-        </p:spPr>
-        <p:txBody>
-          <a:bodyPr wrap="none">
-            <a:spAutoFit/>
-          </a:bodyPr>
-          <a:lstStyle/>
-          <a:p>
-            <a:pPr>
-              <a:defRPr sz="900" b="1">
-                <a:solidFill>
-                  <a:srgbClr val="0284C7"/>
-                </a:solidFill>
-              </a:defRPr>
-            </a:pPr>
-            <a:r>
-              <a:t>(d) Post-Flight Phenotypic Disambiguation Framework</a:t>
-            </a:r>
-          </a:p>
-        </p:txBody>
-      </p:sp>
-      <p:sp>
-        <p:nvSpPr>
-          <p:cNvPr id="17" name="TextBox 16"/>
+              <a:t>(c) Post-Flight Phenotypic Risk Disambiguation Framework (Comparative Matrix)</a:t>
+            </a:r>
+          </a:p>
+        </p:txBody>
+      </p:sp>
+      <p:sp>
+        <p:nvSpPr>
+          <p:cNvPr id="14" name="TextBox 13"/>
           <p:cNvSpPr txBox="1"/>
           <p:nvPr/>
         </p:nvSpPr>

</xml_diff>

<commit_message>
Refine Fig1b arrows/offsets, expand Fig1d/Fig2a boxes, and replace Fig5b with Hardware Self-Magnetic Assessment Protocol
</commit_message>
<xml_diff>
--- a/Near_Null_Magnetic_Fields_Lunar_Plant_Biology_Presentation.pptx
+++ b/Near_Null_Magnetic_Fields_Lunar_Plant_Biology_Presentation.pptx
@@ -721,7 +721,7 @@
           </a:p>
           <a:p>
             <a:r>
-              <a:t>• Panel (b) demonstrates the gold-standard in situ causal reversal protocol: Restoring a calibrated 45 µT vector inside magnetic shielding rescues emergence speed and pigment accumulation, definitively ruling out microclimatic, ethylene, or enclosure artifacts.</a:t>
+              <a:t>• Panel (b) introduces our hardware self-magnetic assessment protocol: Characterizing induced magnetic fields across subsystem operating states (LED PAR lighting, fluidic pumps, thermal heaters, and avionics bus) to establish empirical transfer functions that subtract hardware self-fields without requiring active coils in flight.</a:t>
             </a:r>
           </a:p>
           <a:p>
@@ -5920,7 +5920,7 @@
       </p:sp>
       <p:pic>
         <p:nvPicPr>
-          <p:cNvPr id="9" name="Picture 8" descr="Fig5b_causal_rescue.png"/>
+          <p:cNvPr id="9" name="Picture 8" descr="Fig5b_hardware_assessment.png"/>
           <p:cNvPicPr>
             <a:picLocks noChangeAspect="1"/>
           </p:cNvPicPr>
@@ -5972,7 +5972,7 @@
               </a:defRPr>
             </a:pPr>
             <a:r>
-              <a:t>(b) In Situ Causal Reversal Protocol (Proof of Concept)</a:t>
+              <a:t>(b) Hardware Self-Magnetic Assessment Protocol (Power-State Mapping)</a:t>
             </a:r>
           </a:p>
         </p:txBody>

</xml_diff>

<commit_message>
fix(authors): remove Sofia Leiva Aldana from author list, citations, deck, and metadata
</commit_message>
<xml_diff>
--- a/Near_Null_Magnetic_Fields_Lunar_Plant_Biology_Presentation.pptx
+++ b/Near_Null_Magnetic_Fields_Lunar_Plant_Biology_Presentation.pptx
@@ -532,7 +532,7 @@
           </a:p>
           <a:p>
             <a:r>
-              <a:t>• Co-authored with Marshall Porterfield, Caue Borlina, Aubrey O'Rourke, Adriana Sanchez, Manisha Dagar, Sofia Leiva Aldana, Ray Wheeler, Gioia Massa, Barbara Demmig-Adams, Marta Peirats-Llobet, Pamela Flores, Anirudha Dixit, and Christine Chamberlain.</a:t>
+              <a:t>• Co-authored with Marshall Porterfield, Caue Borlina, Aubrey O'Rourke, Adriana Sanchez, Manisha Dagar, Ray Wheeler, Gioia Massa, Barbara Demmig-Adams, Marta Peirats-Llobet, Pamela Flores, Anirudha Dixit, and Christine Chamberlain.</a:t>
             </a:r>
           </a:p>
           <a:p>
@@ -5206,7 +5206,7 @@
               </a:defRPr>
             </a:pPr>
             <a:r>
-              <a:t>D. Marshall Porterfield*, Richard J. Barker*, Caue Borlina, Aubrey O’Rourke, Adriana Sanchez, Manisha Dagar, Sofia Leiva Aldana,</a:t>
+              <a:t>D. Marshall Porterfield*, Richard J. Barker*, Caue Borlina, Aubrey O’Rourke, Adriana Sanchez, Manisha Dagar,</a:t>
             </a:r>
             <a:br/>
             <a:r>

</xml_diff>

<commit_message>
refactor(abai): replace all Artemis III mentions with Artemis missions across repository and enforce in QC blocklist
</commit_message>
<xml_diff>
--- a/Near_Null_Magnetic_Fields_Lunar_Plant_Biology_Presentation.pptx
+++ b/Near_Null_Magnetic_Fields_Lunar_Plant_Biology_Presentation.pptx
@@ -1497,7 +1497,7 @@
           </a:p>
           <a:p>
             <a:r>
-              <a:t>• Notice from Table 1 that every single candidate landing site for Artemis III and future Artemis missions has a crustal magnetic field below 1 nanotesla.</a:t>
+              <a:t>• Notice from Table 1 that every single candidate landing site for Artemis missions has a crustal magnetic field below 1 nanotesla.</a:t>
             </a:r>
           </a:p>
           <a:p>
@@ -1797,7 +1797,7 @@
           </a:p>
           <a:p>
             <a:r>
-              <a:t>• In field agriculture on Earth, seeds have excess time and buffer. In a tightly scheduled spaceflight payload like LEAF on Artemis III, or a lunar greenhouse, mission timelines are strictly constrained.</a:t>
+              <a:t>• In field agriculture on Earth, seeds have excess time and buffer. In a tightly scheduled spaceflight payload like LEAF on Artemis missions, or a lunar greenhouse, mission timelines are strictly constrained.</a:t>
             </a:r>
           </a:p>
           <a:p>
@@ -5101,7 +5101,7 @@
               </a:defRPr>
             </a:pPr>
             <a:r>
-              <a:t>COSPAR / ELSEVIER REVIEW ARTICLE — ARTEMIS III LEAF PERSPECTIVE</a:t>
+              <a:t>COSPAR / ELSEVIER REVIEW ARTICLE — ARTEMIS MISSIONS LEAF PERSPECTIVE</a:t>
             </a:r>
           </a:p>
         </p:txBody>
@@ -5261,7 +5261,7 @@
               </a:defRPr>
             </a:pPr>
             <a:r>
-              <a:t>Target Journal: Life Sciences in Space Research (LSSR)  |  Mission Context: Artemis III LEAF Payload  |  FAIR Repository &amp; CoSE Portal Ready</a:t>
+              <a:t>Target Journal: Life Sciences in Space Research (LSSR)  |  Mission Context: Artemis Missions LEAF Payload  |  FAIR Repository &amp; CoSE Portal Ready</a:t>
             </a:r>
           </a:p>
         </p:txBody>
@@ -5296,7 +5296,7 @@
               </a:defRPr>
             </a:pPr>
             <a:r>
-              <a:t>Life Sciences in Space Research (2026) | Artemis III LEAF Perspective              Slide 1 of 16</a:t>
+              <a:t>Life Sciences in Space Research (2026) | Artemis Missions LEAF Perspective        Slide 1 of 16</a:t>
             </a:r>
           </a:p>
         </p:txBody>
@@ -5878,7 +5878,7 @@
               </a:defRPr>
             </a:pPr>
             <a:r>
-              <a:t>Life Sciences in Space Research (2026) | Artemis III LEAF Perspective              Slide 10 of 16</a:t>
+              <a:t>Life Sciences in Space Research (2026) | Artemis Missions LEAF Perspective        Slide 10 of 16</a:t>
             </a:r>
           </a:p>
         </p:txBody>
@@ -6316,7 +6316,7 @@
               </a:defRPr>
             </a:pPr>
             <a:r>
-              <a:t>Life Sciences in Space Research (2026) | Artemis III LEAF Perspective              Slide 11 of 16</a:t>
+              <a:t>Life Sciences in Space Research (2026) | Artemis Missions LEAF Perspective        Slide 11 of 16</a:t>
             </a:r>
           </a:p>
         </p:txBody>
@@ -6794,7 +6794,7 @@
               </a:defRPr>
             </a:pPr>
             <a:r>
-              <a:t>Life Sciences in Space Research (2026) | Artemis III LEAF Perspective              Slide 12 of 16</a:t>
+              <a:t>Life Sciences in Space Research (2026) | Artemis Missions LEAF Perspective        Slide 12 of 16</a:t>
             </a:r>
           </a:p>
         </p:txBody>
@@ -7499,7 +7499,7 @@
               </a:defRPr>
             </a:pPr>
             <a:r>
-              <a:t>Life Sciences in Space Research (2026) | Artemis III LEAF Perspective              Slide 13 of 16</a:t>
+              <a:t>Life Sciences in Space Research (2026) | Artemis Missions LEAF Perspective        Slide 13 of 16</a:t>
             </a:r>
           </a:p>
         </p:txBody>
@@ -7977,7 +7977,7 @@
               </a:defRPr>
             </a:pPr>
             <a:r>
-              <a:t>Life Sciences in Space Research (2026) | Artemis III LEAF Perspective              Slide 14 of 16</a:t>
+              <a:t>Life Sciences in Space Research (2026) | Artemis Missions LEAF Perspective        Slide 14 of 16</a:t>
             </a:r>
           </a:p>
         </p:txBody>
@@ -8108,7 +8108,7 @@
               </a:defRPr>
             </a:pPr>
             <a:r>
-              <a:t>Strategic priorities for Artemis III LEAF operations and long-duration lunar bioregenerative life support</a:t>
+              <a:t>Strategic priorities for Artemis missions LEAF operations and long-duration lunar bioregenerative life support</a:t>
             </a:r>
           </a:p>
         </p:txBody>
@@ -8443,7 +8443,7 @@
               </a:defRPr>
             </a:pPr>
             <a:r>
-              <a:t>Life Sciences in Space Research (2026) | Artemis III LEAF Perspective              Slide 15 of 16</a:t>
+              <a:t>Life Sciences in Space Research (2026) | Artemis Missions LEAF Perspective        Slide 15 of 16</a:t>
             </a:r>
           </a:p>
         </p:txBody>
@@ -9025,7 +9025,7 @@
               </a:defRPr>
             </a:pPr>
             <a:r>
-              <a:t>Life Sciences in Space Research (2026) | Artemis III LEAF Perspective              Slide 16 of 16</a:t>
+              <a:t>Life Sciences in Space Research (2026) | Artemis Missions LEAF Perspective        Slide 16 of 16</a:t>
             </a:r>
           </a:p>
         </p:txBody>
@@ -9591,7 +9591,7 @@
               </a:defRPr>
             </a:pPr>
             <a:r>
-              <a:t>Life Sciences in Space Research (2026) | Artemis III LEAF Perspective              Slide 2 of 16</a:t>
+              <a:t>Life Sciences in Space Research (2026) | Artemis Missions LEAF Perspective        Slide 2 of 16</a:t>
             </a:r>
           </a:p>
         </p:txBody>
@@ -10173,7 +10173,7 @@
               </a:defRPr>
             </a:pPr>
             <a:r>
-              <a:t>Life Sciences in Space Research (2026) | Artemis III LEAF Perspective              Slide 3 of 16</a:t>
+              <a:t>Life Sciences in Space Research (2026) | Artemis Missions LEAF Perspective        Slide 3 of 16</a:t>
             </a:r>
           </a:p>
         </p:txBody>
@@ -10634,7 +10634,7 @@
               </a:defRPr>
             </a:pPr>
             <a:r>
-              <a:t>Life Sciences in Space Research (2026) | Artemis III LEAF Perspective              Slide 4 of 16</a:t>
+              <a:t>Life Sciences in Space Research (2026) | Artemis Missions LEAF Perspective        Slide 4 of 16</a:t>
             </a:r>
           </a:p>
         </p:txBody>
@@ -11008,7 +11008,7 @@
               </a:defRPr>
             </a:pPr>
             <a:r>
-              <a:t>Life Sciences in Space Research (2026) | Artemis III LEAF Perspective              Slide 5 of 16</a:t>
+              <a:t>Life Sciences in Space Research (2026) | Artemis Missions LEAF Perspective        Slide 5 of 16</a:t>
             </a:r>
           </a:p>
         </p:txBody>
@@ -11590,7 +11590,7 @@
               </a:defRPr>
             </a:pPr>
             <a:r>
-              <a:t>Life Sciences in Space Research (2026) | Artemis III LEAF Perspective              Slide 6 of 16</a:t>
+              <a:t>Life Sciences in Space Research (2026) | Artemis Missions LEAF Perspective        Slide 6 of 16</a:t>
             </a:r>
           </a:p>
         </p:txBody>
@@ -12037,7 +12037,7 @@
               </a:defRPr>
             </a:pPr>
             <a:r>
-              <a:t>Life Sciences in Space Research (2026) | Artemis III LEAF Perspective              Slide 7 of 16</a:t>
+              <a:t>Life Sciences in Space Research (2026) | Artemis Missions LEAF Perspective        Slide 7 of 16</a:t>
             </a:r>
           </a:p>
         </p:txBody>
@@ -12515,7 +12515,7 @@
               </a:defRPr>
             </a:pPr>
             <a:r>
-              <a:t>Life Sciences in Space Research (2026) | Artemis III LEAF Perspective              Slide 8 of 16</a:t>
+              <a:t>Life Sciences in Space Research (2026) | Artemis Missions LEAF Perspective        Slide 8 of 16</a:t>
             </a:r>
           </a:p>
         </p:txBody>
@@ -12970,7 +12970,7 @@
               </a:defRPr>
             </a:pPr>
             <a:r>
-              <a:t>Life Sciences in Space Research (2026) | Artemis III LEAF Perspective              Slide 9 of 16</a:t>
+              <a:t>Life Sciences in Space Research (2026) | Artemis Missions LEAF Perspective        Slide 9 of 16</a:t>
             </a:r>
           </a:p>
         </p:txBody>

</xml_diff>